<commit_message>
docs: moat slide v2 - plain-English compliance card, backbone wording
Co-Authored-By: Claude Fable 5 <noreply@anthropic.com>
Claude-Session: https://claude.ai/code/session_01QwDVm3mRTGuujstWjPq5KG
</commit_message>
<xml_diff>
--- a/docs/eight-rock-moat-hero.pptx
+++ b/docs/eight-rock-moat-hero.pptx
@@ -1130,7 +1130,7 @@
                 <a:ea typeface="Arial" pitchFamily="34" charset="-122"/>
                 <a:cs typeface="Arial" pitchFamily="34" charset="-120"/>
               </a:rPr>
-              <a:t>Yardi Matrix stops at 50 units. CoStar starts at $40K a year. We built an ownable property spine straight from the public record — </a:t>
+              <a:t>Yardi Matrix stops at 50 units. CoStar starts at $40K a year. We built an ownable property backbone straight from the public record — </a:t>
             </a:r>
             <a:pPr algn="l" indent="0" marL="0">
               <a:buNone/>
@@ -1325,7 +1325,7 @@
                 <a:ea typeface="Arial" pitchFamily="34" charset="-122"/>
                 <a:cs typeface="Arial" pitchFamily="34" charset="-120"/>
               </a:rPr>
-              <a:t>. Our spine has no floor: 19,572 multifamily assets on watch today, at every unit count.</a:t>
+              <a:t>. Our backbone has no floor: 19,572 multifamily assets on watch today, at every unit count.</a:t>
             </a:r>
             <a:endParaRPr lang="en-US" sz="1050" dirty="0"/>
           </a:p>
@@ -1625,7 +1625,7 @@
                 <a:ea typeface="Arial" pitchFamily="34" charset="-122"/>
                 <a:cs typeface="Arial" pitchFamily="34" charset="-120"/>
               </a:rPr>
-              <a:t>No competitor connects find → pierce the LLC → contact → underwrite → verdict. Buyers assemble Reonomy + Terrakotta + redIQ + Dealpath for </a:t>
+              <a:t>Nobody else takes a deal from found, to the real owner behind the LLC, to a call that connects, to an underwritten verdict. Buyers stitch together four subscriptions at </a:t>
             </a:r>
             <a:pPr algn="l" indent="0" marL="0">
               <a:lnSpc>
@@ -1642,7 +1642,7 @@
                 <a:ea typeface="Arial" pitchFamily="34" charset="-122"/>
                 <a:cs typeface="Arial" pitchFamily="34" charset="-120"/>
               </a:rPr>
-              <a:t>$20–40K+/yr across four logins</a:t>
+              <a:t>$20–40K+ a year</a:t>
             </a:r>
             <a:pPr algn="l" indent="0" marL="0">
               <a:lnSpc>
@@ -1659,7 +1659,7 @@
                 <a:ea typeface="Arial" pitchFamily="34" charset="-122"/>
                 <a:cs typeface="Arial" pitchFamily="34" charset="-120"/>
               </a:rPr>
-              <a:t> — and still don’t get the TCPA/DNC compliance gate we ship built-in.</a:t>
+              <a:t> to approximate it. We do it in one login — and every phone number is legally screened against do-not-call rules before anyone dials.</a:t>
             </a:r>
             <a:endParaRPr lang="en-US" sz="1050" dirty="0"/>
           </a:p>
@@ -1985,7 +1985,7 @@
                 <a:ea typeface="Arial" pitchFamily="34" charset="-122"/>
                 <a:cs typeface="Arial" pitchFamily="34" charset="-120"/>
               </a:rPr>
-              <a:t>THE 8R SPINE</a:t>
+              <a:t>THE 8R BACKBONE</a:t>
             </a:r>
             <a:endParaRPr lang="en-US" sz="1150" dirty="0"/>
           </a:p>

</xml_diff>

<commit_message>
docs: moat slide v3 - full lifecycle strip, operator signature, Aug 1
Co-Authored-By: Claude Fable 5 <noreply@anthropic.com>
Claude-Session: https://claude.ai/code/session_01QwDVm3mRTGuujstWjPq5KG
</commit_message>
<xml_diff>
--- a/docs/eight-rock-moat-hero.pptx
+++ b/docs/eight-rock-moat-hero.pptx
@@ -1000,8 +1000,8 @@
         </p:nvSpPr>
         <p:spPr>
           <a:xfrm>
-            <a:off x="9646920" y="329184"/>
-            <a:ext cx="2130552" cy="402336"/>
+            <a:off x="9400032" y="329184"/>
+            <a:ext cx="2377440" cy="402336"/>
           </a:xfrm>
           <a:prstGeom prst="roundRect">
             <a:avLst>
@@ -1027,8 +1027,8 @@
         </p:nvSpPr>
         <p:spPr>
           <a:xfrm>
-            <a:off x="9646920" y="329184"/>
-            <a:ext cx="2130552" cy="402336"/>
+            <a:off x="9400032" y="329184"/>
+            <a:ext cx="2377440" cy="402336"/>
           </a:xfrm>
           <a:prstGeom prst="rect">
             <a:avLst/>
@@ -1052,7 +1052,7 @@
                 <a:ea typeface="Arial" pitchFamily="34" charset="-122"/>
                 <a:cs typeface="Arial" pitchFamily="34" charset="-120"/>
               </a:rPr>
-              <a:t>LIVE IN PRODUCTION · JUL 2026</a:t>
+              <a:t>LIVE IN PRODUCTION · AUG 1, 2026</a:t>
             </a:r>
             <a:endParaRPr lang="en-US" sz="950" dirty="0"/>
           </a:p>
@@ -1667,18 +1667,57 @@
       </p:sp>
       <p:sp>
         <p:nvSpPr>
-          <p:cNvPr id="21" name="Shape 19"/>
-          <p:cNvSpPr/>
-          <p:nvPr/>
-        </p:nvSpPr>
-        <p:spPr>
-          <a:xfrm>
-            <a:off x="411480" y="4498848"/>
-            <a:ext cx="2670048" cy="841248"/>
+          <p:cNvPr id="21" name="Text 19"/>
+          <p:cNvSpPr/>
+          <p:nvPr/>
+        </p:nvSpPr>
+        <p:spPr>
+          <a:xfrm>
+            <a:off x="411480" y="4352544"/>
+            <a:ext cx="11365992" cy="201168"/>
+          </a:xfrm>
+          <a:prstGeom prst="rect">
+            <a:avLst/>
+          </a:prstGeom>
+          <a:noFill/>
+          <a:ln/>
+        </p:spPr>
+        <p:txBody>
+          <a:bodyPr wrap="square" lIns="0" tIns="0" rIns="0" bIns="0" rtlCol="0" anchor="ctr"/>
+          <a:lstStyle/>
+          <a:p>
+            <a:pPr algn="l" indent="0" marL="0">
+              <a:buNone/>
+            </a:pPr>
+            <a:r>
+              <a:rPr lang="en-US" sz="1050" b="1" spc="200" kern="0" dirty="0">
+                <a:solidFill>
+                  <a:srgbClr val="94A0B3"/>
+                </a:solidFill>
+                <a:latin typeface="Arial" pitchFamily="34" charset="0"/>
+                <a:ea typeface="Arial" pitchFamily="34" charset="-122"/>
+                <a:cs typeface="Arial" pitchFamily="34" charset="-120"/>
+              </a:rPr>
+              <a:t>THE WHOLE LIFECYCLE. ONE LOGIN.</a:t>
+            </a:r>
+            <a:endParaRPr lang="en-US" sz="1050" dirty="0"/>
+          </a:p>
+        </p:txBody>
+      </p:sp>
+      <p:sp>
+        <p:nvSpPr>
+          <p:cNvPr id="22" name="Shape 20"/>
+          <p:cNvSpPr/>
+          <p:nvPr/>
+        </p:nvSpPr>
+        <p:spPr>
+          <a:xfrm>
+            <a:off x="411480" y="4590288"/>
+            <a:ext cx="2670048" cy="804672"/>
           </a:xfrm>
           <a:prstGeom prst="roundRect">
             <a:avLst>
-              <a:gd name="adj" fmla="val 8696"/>
+              <a:gd name="adj" fmla="val 9091"/>
             </a:avLst>
           </a:prstGeom>
           <a:solidFill>
@@ -1694,13 +1733,13 @@
       </p:sp>
       <p:sp>
         <p:nvSpPr>
-          <p:cNvPr id="22" name="Text 20"/>
-          <p:cNvSpPr/>
-          <p:nvPr/>
-        </p:nvSpPr>
-        <p:spPr>
-          <a:xfrm>
-            <a:off x="539496" y="4608576"/>
+          <p:cNvPr id="23" name="Text 21"/>
+          <p:cNvSpPr/>
+          <p:nvPr/>
+        </p:nvSpPr>
+        <p:spPr>
+          <a:xfrm>
+            <a:off x="539496" y="4700016"/>
             <a:ext cx="2414016" cy="274320"/>
           </a:xfrm>
           <a:prstGeom prst="rect">
@@ -1725,7 +1764,7 @@
                 <a:ea typeface="Arial" pitchFamily="34" charset="-122"/>
                 <a:cs typeface="Arial" pitchFamily="34" charset="-120"/>
               </a:rPr>
-              <a:t>PUBLIC RECORD</a:t>
+              <a:t>ACQUIRE</a:t>
             </a:r>
             <a:endParaRPr lang="en-US" sz="1150" dirty="0"/>
           </a:p>
@@ -1733,13 +1772,13 @@
       </p:sp>
       <p:sp>
         <p:nvSpPr>
-          <p:cNvPr id="23" name="Text 21"/>
-          <p:cNvSpPr/>
-          <p:nvPr/>
-        </p:nvSpPr>
-        <p:spPr>
-          <a:xfrm>
-            <a:off x="539496" y="4901184"/>
+          <p:cNvPr id="24" name="Text 22"/>
+          <p:cNvSpPr/>
+          <p:nvPr/>
+        </p:nvSpPr>
+        <p:spPr>
+          <a:xfrm>
+            <a:off x="539496" y="4992624"/>
             <a:ext cx="2414016" cy="329184"/>
           </a:xfrm>
           <a:prstGeom prst="rect">
@@ -1764,7 +1803,7 @@
                 <a:ea typeface="Arial" pitchFamily="34" charset="-122"/>
                 <a:cs typeface="Arial" pitchFamily="34" charset="-120"/>
               </a:rPr>
-              <a:t>17 live feeds · 3.67M records</a:t>
+              <a:t>source off-market · reach the owner · underwrite</a:t>
             </a:r>
             <a:endParaRPr lang="en-US" sz="900" dirty="0"/>
           </a:p>
@@ -1772,13 +1811,13 @@
       </p:sp>
       <p:sp>
         <p:nvSpPr>
-          <p:cNvPr id="24" name="Shape 22"/>
-          <p:cNvSpPr/>
-          <p:nvPr/>
-        </p:nvSpPr>
-        <p:spPr>
-          <a:xfrm>
-            <a:off x="3099816" y="4818888"/>
+          <p:cNvPr id="25" name="Shape 23"/>
+          <p:cNvSpPr/>
+          <p:nvPr/>
+        </p:nvSpPr>
+        <p:spPr>
+          <a:xfrm>
+            <a:off x="3099816" y="4892040"/>
             <a:ext cx="182880" cy="201168"/>
           </a:xfrm>
           <a:prstGeom prst="chevron">
@@ -1797,18 +1836,18 @@
       </p:sp>
       <p:sp>
         <p:nvSpPr>
-          <p:cNvPr id="25" name="Shape 23"/>
-          <p:cNvSpPr/>
-          <p:nvPr/>
-        </p:nvSpPr>
-        <p:spPr>
-          <a:xfrm>
-            <a:off x="3305556" y="4498848"/>
-            <a:ext cx="2670048" cy="841248"/>
+          <p:cNvPr id="26" name="Shape 24"/>
+          <p:cNvSpPr/>
+          <p:nvPr/>
+        </p:nvSpPr>
+        <p:spPr>
+          <a:xfrm>
+            <a:off x="3305556" y="4590288"/>
+            <a:ext cx="2670048" cy="804672"/>
           </a:xfrm>
           <a:prstGeom prst="roundRect">
             <a:avLst>
-              <a:gd name="adj" fmla="val 8696"/>
+              <a:gd name="adj" fmla="val 9091"/>
             </a:avLst>
           </a:prstGeom>
           <a:solidFill>
@@ -1824,13 +1863,13 @@
       </p:sp>
       <p:sp>
         <p:nvSpPr>
-          <p:cNvPr id="26" name="Text 24"/>
-          <p:cNvSpPr/>
-          <p:nvPr/>
-        </p:nvSpPr>
-        <p:spPr>
-          <a:xfrm>
-            <a:off x="3433572" y="4608576"/>
+          <p:cNvPr id="27" name="Text 25"/>
+          <p:cNvSpPr/>
+          <p:nvPr/>
+        </p:nvSpPr>
+        <p:spPr>
+          <a:xfrm>
+            <a:off x="3433572" y="4700016"/>
             <a:ext cx="2414016" cy="274320"/>
           </a:xfrm>
           <a:prstGeom prst="rect">
@@ -1855,7 +1894,7 @@
                 <a:ea typeface="Arial" pitchFamily="34" charset="-122"/>
                 <a:cs typeface="Arial" pitchFamily="34" charset="-120"/>
               </a:rPr>
-              <a:t>SELF-TUNING ETL</a:t>
+              <a:t>OPERATE</a:t>
             </a:r>
             <a:endParaRPr lang="en-US" sz="1150" dirty="0"/>
           </a:p>
@@ -1863,13 +1902,13 @@
       </p:sp>
       <p:sp>
         <p:nvSpPr>
-          <p:cNvPr id="27" name="Text 25"/>
-          <p:cNvSpPr/>
-          <p:nvPr/>
-        </p:nvSpPr>
-        <p:spPr>
-          <a:xfrm>
-            <a:off x="3433572" y="4901184"/>
+          <p:cNvPr id="28" name="Text 26"/>
+          <p:cNvSpPr/>
+          <p:nvPr/>
+        </p:nvSpPr>
+        <p:spPr>
+          <a:xfrm>
+            <a:off x="3433572" y="4992624"/>
             <a:ext cx="2414016" cy="329184"/>
           </a:xfrm>
           <a:prstGeom prst="rect">
@@ -1894,7 +1933,7 @@
                 <a:ea typeface="Arial" pitchFamily="34" charset="-122"/>
                 <a:cs typeface="Arial" pitchFamily="34" charset="-120"/>
               </a:rPr>
-              <a:t>discovers · verifies · heals</a:t>
+              <a:t>syncs with AppFolio &amp; your PM stack</a:t>
             </a:r>
             <a:endParaRPr lang="en-US" sz="900" dirty="0"/>
           </a:p>
@@ -1902,13 +1941,13 @@
       </p:sp>
       <p:sp>
         <p:nvSpPr>
-          <p:cNvPr id="28" name="Shape 26"/>
-          <p:cNvSpPr/>
-          <p:nvPr/>
-        </p:nvSpPr>
-        <p:spPr>
-          <a:xfrm>
-            <a:off x="5993892" y="4818888"/>
+          <p:cNvPr id="29" name="Shape 27"/>
+          <p:cNvSpPr/>
+          <p:nvPr/>
+        </p:nvSpPr>
+        <p:spPr>
+          <a:xfrm>
+            <a:off x="5993892" y="4892040"/>
             <a:ext cx="182880" cy="201168"/>
           </a:xfrm>
           <a:prstGeom prst="chevron">
@@ -1927,18 +1966,18 @@
       </p:sp>
       <p:sp>
         <p:nvSpPr>
-          <p:cNvPr id="29" name="Shape 27"/>
-          <p:cNvSpPr/>
-          <p:nvPr/>
-        </p:nvSpPr>
-        <p:spPr>
-          <a:xfrm>
-            <a:off x="6199632" y="4498848"/>
-            <a:ext cx="2670048" cy="841248"/>
+          <p:cNvPr id="30" name="Shape 28"/>
+          <p:cNvSpPr/>
+          <p:nvPr/>
+        </p:nvSpPr>
+        <p:spPr>
+          <a:xfrm>
+            <a:off x="6199632" y="4590288"/>
+            <a:ext cx="2670048" cy="804672"/>
           </a:xfrm>
           <a:prstGeom prst="roundRect">
             <a:avLst>
-              <a:gd name="adj" fmla="val 8696"/>
+              <a:gd name="adj" fmla="val 9091"/>
             </a:avLst>
           </a:prstGeom>
           <a:solidFill>
@@ -1954,13 +1993,13 @@
       </p:sp>
       <p:sp>
         <p:nvSpPr>
-          <p:cNvPr id="30" name="Text 28"/>
-          <p:cNvSpPr/>
-          <p:nvPr/>
-        </p:nvSpPr>
-        <p:spPr>
-          <a:xfrm>
-            <a:off x="6327648" y="4608576"/>
+          <p:cNvPr id="31" name="Text 29"/>
+          <p:cNvSpPr/>
+          <p:nvPr/>
+        </p:nvSpPr>
+        <p:spPr>
+          <a:xfrm>
+            <a:off x="6327648" y="4700016"/>
             <a:ext cx="2414016" cy="274320"/>
           </a:xfrm>
           <a:prstGeom prst="rect">
@@ -1985,7 +2024,7 @@
                 <a:ea typeface="Arial" pitchFamily="34" charset="-122"/>
                 <a:cs typeface="Arial" pitchFamily="34" charset="-120"/>
               </a:rPr>
-              <a:t>THE 8R BACKBONE</a:t>
+              <a:t>DISTRIBUTE</a:t>
             </a:r>
             <a:endParaRPr lang="en-US" sz="1150" dirty="0"/>
           </a:p>
@@ -1993,13 +2032,13 @@
       </p:sp>
       <p:sp>
         <p:nvSpPr>
-          <p:cNvPr id="31" name="Text 29"/>
-          <p:cNvSpPr/>
-          <p:nvPr/>
-        </p:nvSpPr>
-        <p:spPr>
-          <a:xfrm>
-            <a:off x="6327648" y="4901184"/>
+          <p:cNvPr id="32" name="Text 30"/>
+          <p:cNvSpPr/>
+          <p:nvPr/>
+        </p:nvSpPr>
+        <p:spPr>
+          <a:xfrm>
+            <a:off x="6327648" y="4992624"/>
             <a:ext cx="2414016" cy="329184"/>
           </a:xfrm>
           <a:prstGeom prst="rect">
@@ -2024,7 +2063,7 @@
                 <a:ea typeface="Arial" pitchFamily="34" charset="-122"/>
                 <a:cs typeface="Arial" pitchFamily="34" charset="-120"/>
               </a:rPr>
-              <a:t>939,937 parcels · owned outright</a:t>
+              <a:t>LP/GP waterfalls · K-1-ready for your CPA</a:t>
             </a:r>
             <a:endParaRPr lang="en-US" sz="900" dirty="0"/>
           </a:p>
@@ -2032,13 +2071,13 @@
       </p:sp>
       <p:sp>
         <p:nvSpPr>
-          <p:cNvPr id="32" name="Shape 30"/>
-          <p:cNvSpPr/>
-          <p:nvPr/>
-        </p:nvSpPr>
-        <p:spPr>
-          <a:xfrm>
-            <a:off x="8887968" y="4818888"/>
+          <p:cNvPr id="33" name="Shape 31"/>
+          <p:cNvSpPr/>
+          <p:nvPr/>
+        </p:nvSpPr>
+        <p:spPr>
+          <a:xfrm>
+            <a:off x="8887968" y="4892040"/>
             <a:ext cx="182880" cy="201168"/>
           </a:xfrm>
           <a:prstGeom prst="chevron">
@@ -2057,18 +2096,18 @@
       </p:sp>
       <p:sp>
         <p:nvSpPr>
-          <p:cNvPr id="33" name="Shape 31"/>
-          <p:cNvSpPr/>
-          <p:nvPr/>
-        </p:nvSpPr>
-        <p:spPr>
-          <a:xfrm>
-            <a:off x="9093708" y="4498848"/>
-            <a:ext cx="2670048" cy="841248"/>
+          <p:cNvPr id="34" name="Shape 32"/>
+          <p:cNvSpPr/>
+          <p:nvPr/>
+        </p:nvSpPr>
+        <p:spPr>
+          <a:xfrm>
+            <a:off x="9093708" y="4590288"/>
+            <a:ext cx="2670048" cy="804672"/>
           </a:xfrm>
           <a:prstGeom prst="roundRect">
             <a:avLst>
-              <a:gd name="adj" fmla="val 8696"/>
+              <a:gd name="adj" fmla="val 9091"/>
             </a:avLst>
           </a:prstGeom>
           <a:solidFill>
@@ -2084,13 +2123,13 @@
       </p:sp>
       <p:sp>
         <p:nvSpPr>
-          <p:cNvPr id="34" name="Text 32"/>
-          <p:cNvSpPr/>
-          <p:nvPr/>
-        </p:nvSpPr>
-        <p:spPr>
-          <a:xfrm>
-            <a:off x="9221724" y="4608576"/>
+          <p:cNvPr id="35" name="Text 33"/>
+          <p:cNvSpPr/>
+          <p:nvPr/>
+        </p:nvSpPr>
+        <p:spPr>
+          <a:xfrm>
+            <a:off x="9221724" y="4700016"/>
             <a:ext cx="2414016" cy="274320"/>
           </a:xfrm>
           <a:prstGeom prst="rect">
@@ -2115,7 +2154,7 @@
                 <a:ea typeface="Arial" pitchFamily="34" charset="-122"/>
                 <a:cs typeface="Arial" pitchFamily="34" charset="-120"/>
               </a:rPr>
-              <a:t>FULL-LOOP PLATFORM</a:t>
+              <a:t>MONITOR</a:t>
             </a:r>
             <a:endParaRPr lang="en-US" sz="1150" dirty="0"/>
           </a:p>
@@ -2123,13 +2162,13 @@
       </p:sp>
       <p:sp>
         <p:nvSpPr>
-          <p:cNvPr id="35" name="Text 33"/>
-          <p:cNvSpPr/>
-          <p:nvPr/>
-        </p:nvSpPr>
-        <p:spPr>
-          <a:xfrm>
-            <a:off x="9221724" y="4901184"/>
+          <p:cNvPr id="36" name="Text 34"/>
+          <p:cNvSpPr/>
+          <p:nvPr/>
+        </p:nvSpPr>
+        <p:spPr>
+          <a:xfrm>
+            <a:off x="9221724" y="4992624"/>
             <a:ext cx="2414016" cy="329184"/>
           </a:xfrm>
           <a:prstGeom prst="rect">
@@ -2154,7 +2193,7 @@
                 <a:ea typeface="Arial" pitchFamily="34" charset="-122"/>
                 <a:cs typeface="Arial" pitchFamily="34" charset="-120"/>
               </a:rPr>
-              <a:t>source → pierce → underwrite → close</a:t>
+              <a:t>portfolio health on one screen</a:t>
             </a:r>
             <a:endParaRPr lang="en-US" sz="900" dirty="0"/>
           </a:p>
@@ -2162,18 +2201,18 @@
       </p:sp>
       <p:sp>
         <p:nvSpPr>
-          <p:cNvPr id="36" name="Shape 34"/>
-          <p:cNvSpPr/>
-          <p:nvPr/>
-        </p:nvSpPr>
-        <p:spPr>
-          <a:xfrm>
-            <a:off x="411480" y="5541264"/>
-            <a:ext cx="11365992" cy="932688"/>
+          <p:cNvPr id="37" name="Shape 35"/>
+          <p:cNvSpPr/>
+          <p:nvPr/>
+        </p:nvSpPr>
+        <p:spPr>
+          <a:xfrm>
+            <a:off x="411480" y="5504688"/>
+            <a:ext cx="11365992" cy="987552"/>
           </a:xfrm>
           <a:prstGeom prst="roundRect">
             <a:avLst>
-              <a:gd name="adj" fmla="val 8824"/>
+              <a:gd name="adj" fmla="val 8333"/>
             </a:avLst>
           </a:prstGeom>
           <a:solidFill>
@@ -2189,14 +2228,14 @@
       </p:sp>
       <p:sp>
         <p:nvSpPr>
-          <p:cNvPr id="37" name="Text 35"/>
-          <p:cNvSpPr/>
-          <p:nvPr/>
-        </p:nvSpPr>
-        <p:spPr>
-          <a:xfrm>
-            <a:off x="658368" y="5669280"/>
-            <a:ext cx="5577840" cy="310896"/>
+          <p:cNvPr id="38" name="Text 36"/>
+          <p:cNvSpPr/>
+          <p:nvPr/>
+        </p:nvSpPr>
+        <p:spPr>
+          <a:xfrm>
+            <a:off x="658368" y="5596128"/>
+            <a:ext cx="5577840" cy="237744"/>
           </a:xfrm>
           <a:prstGeom prst="rect">
             <a:avLst/>
@@ -2212,7 +2251,7 @@
               <a:buNone/>
             </a:pPr>
             <a:r>
-              <a:rPr lang="en-US" sz="1000" b="1" spc="200" kern="0" dirty="0">
+              <a:rPr lang="en-US" sz="950" b="1" spc="200" kern="0" dirty="0">
                 <a:solidFill>
                   <a:srgbClr val="94A0B3"/>
                 </a:solidFill>
@@ -2226,7 +2265,7 @@
               <a:buNone/>
             </a:pPr>
             <a:r>
-              <a:rPr lang="en-US" sz="1000" b="1" dirty="0">
+              <a:rPr lang="en-US" sz="950" b="1" dirty="0">
                 <a:solidFill>
                   <a:srgbClr val="F5F7FB"/>
                 </a:solidFill>
@@ -2236,20 +2275,98 @@
               </a:rPr>
               <a:t>YARDI MATRIX · COSTAR · REONOMY · TERRAKOTTA · REDIQ · DEALPATH</a:t>
             </a:r>
+            <a:endParaRPr lang="en-US" sz="950" dirty="0"/>
+          </a:p>
+        </p:txBody>
+      </p:sp>
+      <p:sp>
+        <p:nvSpPr>
+          <p:cNvPr id="39" name="Text 37"/>
+          <p:cNvSpPr/>
+          <p:nvPr/>
+        </p:nvSpPr>
+        <p:spPr>
+          <a:xfrm>
+            <a:off x="658368" y="5852160"/>
+            <a:ext cx="5486400" cy="347472"/>
+          </a:xfrm>
+          <a:prstGeom prst="rect">
+            <a:avLst/>
+          </a:prstGeom>
+          <a:noFill/>
+          <a:ln/>
+        </p:spPr>
+        <p:txBody>
+          <a:bodyPr wrap="square" lIns="0" tIns="0" rIns="0" bIns="0" rtlCol="0" anchor="t"/>
+          <a:lstStyle/>
+          <a:p>
+            <a:pPr algn="l" indent="0" marL="0">
+              <a:buNone/>
+            </a:pPr>
+            <a:r>
+              <a:rPr lang="en-US" sz="950" dirty="0">
+                <a:solidFill>
+                  <a:srgbClr val="BDC5D6"/>
+                </a:solidFill>
+                <a:latin typeface="Arial" pitchFamily="34" charset="0"/>
+                <a:ea typeface="Arial" pitchFamily="34" charset="-122"/>
+                <a:cs typeface="Arial" pitchFamily="34" charset="-120"/>
+              </a:rPr>
+              <a:t>The full suite the small and mid-size shop could never afford — priced for the shop, not the institution. </a:t>
+            </a:r>
+            <a:endParaRPr lang="en-US" sz="950" dirty="0"/>
+          </a:p>
+        </p:txBody>
+      </p:sp>
+      <p:sp>
+        <p:nvSpPr>
+          <p:cNvPr id="40" name="Text 38"/>
+          <p:cNvSpPr/>
+          <p:nvPr/>
+        </p:nvSpPr>
+        <p:spPr>
+          <a:xfrm>
+            <a:off x="658368" y="6199632"/>
+            <a:ext cx="5486400" cy="237744"/>
+          </a:xfrm>
+          <a:prstGeom prst="rect">
+            <a:avLst/>
+          </a:prstGeom>
+          <a:noFill/>
+          <a:ln/>
+        </p:spPr>
+        <p:txBody>
+          <a:bodyPr wrap="square" lIns="0" tIns="0" rIns="0" bIns="0" rtlCol="0" anchor="ctr"/>
+          <a:lstStyle/>
+          <a:p>
+            <a:pPr algn="l" indent="0" marL="0">
+              <a:buNone/>
+            </a:pPr>
+            <a:r>
+              <a:rPr lang="en-US" sz="1000" b="1" i="1" dirty="0">
+                <a:solidFill>
+                  <a:srgbClr val="F7D060"/>
+                </a:solidFill>
+                <a:latin typeface="Arial" pitchFamily="34" charset="0"/>
+                <a:ea typeface="Arial" pitchFamily="34" charset="-122"/>
+                <a:cs typeface="Arial" pitchFamily="34" charset="-120"/>
+              </a:rPr>
+              <a:t>Purpose-built by CRE owners &amp; operators, for CRE owners &amp; operators.</a:t>
+            </a:r>
             <a:endParaRPr lang="en-US" sz="1000" dirty="0"/>
           </a:p>
         </p:txBody>
       </p:sp>
       <p:sp>
         <p:nvSpPr>
-          <p:cNvPr id="38" name="Text 36"/>
-          <p:cNvSpPr/>
-          <p:nvPr/>
-        </p:nvSpPr>
-        <p:spPr>
-          <a:xfrm>
-            <a:off x="658368" y="5998464"/>
-            <a:ext cx="5394960" cy="310896"/>
+          <p:cNvPr id="41" name="Text 39"/>
+          <p:cNvSpPr/>
+          <p:nvPr/>
+        </p:nvSpPr>
+        <p:spPr>
+          <a:xfrm>
+            <a:off x="6309360" y="5650992"/>
+            <a:ext cx="1298448" cy="457200"/>
           </a:xfrm>
           <a:prstGeom prst="rect">
             <a:avLst/>
@@ -2261,11 +2378,50 @@
           <a:bodyPr wrap="square" lIns="0" tIns="0" rIns="0" bIns="0" rtlCol="0" anchor="ctr"/>
           <a:lstStyle/>
           <a:p>
-            <a:pPr algn="l" indent="0" marL="0">
-              <a:buNone/>
-            </a:pPr>
-            <a:r>
-              <a:rPr lang="en-US" sz="1000" i="1" dirty="0">
+            <a:pPr algn="ctr" indent="0" marL="0">
+              <a:buNone/>
+            </a:pPr>
+            <a:r>
+              <a:rPr lang="en-US" sz="2200" b="1" dirty="0">
+                <a:solidFill>
+                  <a:srgbClr val="F7D060"/>
+                </a:solidFill>
+                <a:latin typeface="Arial" pitchFamily="34" charset="0"/>
+                <a:ea typeface="Arial" pitchFamily="34" charset="-122"/>
+                <a:cs typeface="Arial" pitchFamily="34" charset="-120"/>
+              </a:rPr>
+              <a:t>50</a:t>
+            </a:r>
+            <a:endParaRPr lang="en-US" sz="2200" dirty="0"/>
+          </a:p>
+        </p:txBody>
+      </p:sp>
+      <p:sp>
+        <p:nvSpPr>
+          <p:cNvPr id="42" name="Text 40"/>
+          <p:cNvSpPr/>
+          <p:nvPr/>
+        </p:nvSpPr>
+        <p:spPr>
+          <a:xfrm>
+            <a:off x="6309360" y="6089904"/>
+            <a:ext cx="1298448" cy="274320"/>
+          </a:xfrm>
+          <a:prstGeom prst="rect">
+            <a:avLst/>
+          </a:prstGeom>
+          <a:noFill/>
+          <a:ln/>
+        </p:spPr>
+        <p:txBody>
+          <a:bodyPr wrap="square" lIns="0" tIns="0" rIns="0" bIns="0" rtlCol="0" anchor="t"/>
+          <a:lstStyle/>
+          <a:p>
+            <a:pPr algn="ctr" indent="0" marL="0">
+              <a:buNone/>
+            </a:pPr>
+            <a:r>
+              <a:rPr lang="en-US" sz="900" dirty="0">
                 <a:solidFill>
                   <a:srgbClr val="94A0B3"/>
                 </a:solidFill>
@@ -2273,21 +2429,21 @@
                 <a:ea typeface="Arial" pitchFamily="34" charset="-122"/>
                 <a:cs typeface="Arial" pitchFamily="34" charset="-120"/>
               </a:rPr>
-              <a:t>One platform. Transparent pricing. Built for the segment the giants price out.</a:t>
-            </a:r>
-            <a:endParaRPr lang="en-US" sz="1000" dirty="0"/>
-          </a:p>
-        </p:txBody>
-      </p:sp>
-      <p:sp>
-        <p:nvSpPr>
-          <p:cNvPr id="39" name="Text 37"/>
-          <p:cNvSpPr/>
-          <p:nvPr/>
-        </p:nvSpPr>
-        <p:spPr>
-          <a:xfrm>
-            <a:off x="6309360" y="5632704"/>
+              <a:t>metros next</a:t>
+            </a:r>
+            <a:endParaRPr lang="en-US" sz="900" dirty="0"/>
+          </a:p>
+        </p:txBody>
+      </p:sp>
+      <p:sp>
+        <p:nvSpPr>
+          <p:cNvPr id="43" name="Text 41"/>
+          <p:cNvSpPr/>
+          <p:nvPr/>
+        </p:nvSpPr>
+        <p:spPr>
+          <a:xfrm>
+            <a:off x="7653528" y="5650992"/>
             <a:ext cx="1298448" cy="457200"/>
           </a:xfrm>
           <a:prstGeom prst="rect">
@@ -2312,7 +2468,7 @@
                 <a:ea typeface="Arial" pitchFamily="34" charset="-122"/>
                 <a:cs typeface="Arial" pitchFamily="34" charset="-120"/>
               </a:rPr>
-              <a:t>50</a:t>
+              <a:t>30–60M</a:t>
             </a:r>
             <a:endParaRPr lang="en-US" sz="2200" dirty="0"/>
           </a:p>
@@ -2320,13 +2476,13 @@
       </p:sp>
       <p:sp>
         <p:nvSpPr>
-          <p:cNvPr id="40" name="Text 38"/>
-          <p:cNvSpPr/>
-          <p:nvPr/>
-        </p:nvSpPr>
-        <p:spPr>
-          <a:xfrm>
-            <a:off x="6309360" y="6071616"/>
+          <p:cNvPr id="44" name="Text 42"/>
+          <p:cNvSpPr/>
+          <p:nvPr/>
+        </p:nvSpPr>
+        <p:spPr>
+          <a:xfrm>
+            <a:off x="7653528" y="6089904"/>
             <a:ext cx="1298448" cy="274320"/>
           </a:xfrm>
           <a:prstGeom prst="rect">
@@ -2351,7 +2507,7 @@
                 <a:ea typeface="Arial" pitchFamily="34" charset="-122"/>
                 <a:cs typeface="Arial" pitchFamily="34" charset="-120"/>
               </a:rPr>
-              <a:t>metros next</a:t>
+              <a:t>parcels</a:t>
             </a:r>
             <a:endParaRPr lang="en-US" sz="900" dirty="0"/>
           </a:p>
@@ -2359,13 +2515,13 @@
       </p:sp>
       <p:sp>
         <p:nvSpPr>
-          <p:cNvPr id="41" name="Text 39"/>
-          <p:cNvSpPr/>
-          <p:nvPr/>
-        </p:nvSpPr>
-        <p:spPr>
-          <a:xfrm>
-            <a:off x="7653528" y="5632704"/>
+          <p:cNvPr id="45" name="Text 43"/>
+          <p:cNvSpPr/>
+          <p:nvPr/>
+        </p:nvSpPr>
+        <p:spPr>
+          <a:xfrm>
+            <a:off x="8997696" y="5650992"/>
             <a:ext cx="1298448" cy="457200"/>
           </a:xfrm>
           <a:prstGeom prst="rect">
@@ -2390,7 +2546,7 @@
                 <a:ea typeface="Arial" pitchFamily="34" charset="-122"/>
                 <a:cs typeface="Arial" pitchFamily="34" charset="-120"/>
               </a:rPr>
-              <a:t>30–60M</a:t>
+              <a:t>&lt; 4 hrs</a:t>
             </a:r>
             <a:endParaRPr lang="en-US" sz="2200" dirty="0"/>
           </a:p>
@@ -2398,13 +2554,13 @@
       </p:sp>
       <p:sp>
         <p:nvSpPr>
-          <p:cNvPr id="42" name="Text 40"/>
-          <p:cNvSpPr/>
-          <p:nvPr/>
-        </p:nvSpPr>
-        <p:spPr>
-          <a:xfrm>
-            <a:off x="7653528" y="6071616"/>
+          <p:cNvPr id="46" name="Text 44"/>
+          <p:cNvSpPr/>
+          <p:nvPr/>
+        </p:nvSpPr>
+        <p:spPr>
+          <a:xfrm>
+            <a:off x="8997696" y="6089904"/>
             <a:ext cx="1298448" cy="274320"/>
           </a:xfrm>
           <a:prstGeom prst="rect">
@@ -2429,7 +2585,7 @@
                 <a:ea typeface="Arial" pitchFamily="34" charset="-122"/>
                 <a:cs typeface="Arial" pitchFamily="34" charset="-120"/>
               </a:rPr>
-              <a:t>parcels</a:t>
+              <a:t>full refresh</a:t>
             </a:r>
             <a:endParaRPr lang="en-US" sz="900" dirty="0"/>
           </a:p>
@@ -2437,13 +2593,13 @@
       </p:sp>
       <p:sp>
         <p:nvSpPr>
-          <p:cNvPr id="43" name="Text 41"/>
-          <p:cNvSpPr/>
-          <p:nvPr/>
-        </p:nvSpPr>
-        <p:spPr>
-          <a:xfrm>
-            <a:off x="8997696" y="5632704"/>
+          <p:cNvPr id="47" name="Text 45"/>
+          <p:cNvSpPr/>
+          <p:nvPr/>
+        </p:nvSpPr>
+        <p:spPr>
+          <a:xfrm>
+            <a:off x="10341864" y="5650992"/>
             <a:ext cx="1298448" cy="457200"/>
           </a:xfrm>
           <a:prstGeom prst="rect">
@@ -2468,7 +2624,7 @@
                 <a:ea typeface="Arial" pitchFamily="34" charset="-122"/>
                 <a:cs typeface="Arial" pitchFamily="34" charset="-120"/>
               </a:rPr>
-              <a:t>&lt; 4 hrs</a:t>
+              <a:t>$0</a:t>
             </a:r>
             <a:endParaRPr lang="en-US" sz="2200" dirty="0"/>
           </a:p>
@@ -2476,13 +2632,13 @@
       </p:sp>
       <p:sp>
         <p:nvSpPr>
-          <p:cNvPr id="44" name="Text 42"/>
-          <p:cNvSpPr/>
-          <p:nvPr/>
-        </p:nvSpPr>
-        <p:spPr>
-          <a:xfrm>
-            <a:off x="8997696" y="6071616"/>
+          <p:cNvPr id="48" name="Text 46"/>
+          <p:cNvSpPr/>
+          <p:nvPr/>
+        </p:nvSpPr>
+        <p:spPr>
+          <a:xfrm>
+            <a:off x="10341864" y="6089904"/>
             <a:ext cx="1298448" cy="274320"/>
           </a:xfrm>
           <a:prstGeom prst="rect">
@@ -2507,7 +2663,7 @@
                 <a:ea typeface="Arial" pitchFamily="34" charset="-122"/>
                 <a:cs typeface="Arial" pitchFamily="34" charset="-120"/>
               </a:rPr>
-              <a:t>full refresh</a:t>
+              <a:t>data licenses</a:t>
             </a:r>
             <a:endParaRPr lang="en-US" sz="900" dirty="0"/>
           </a:p>
@@ -2515,91 +2671,13 @@
       </p:sp>
       <p:sp>
         <p:nvSpPr>
-          <p:cNvPr id="45" name="Text 43"/>
-          <p:cNvSpPr/>
-          <p:nvPr/>
-        </p:nvSpPr>
-        <p:spPr>
-          <a:xfrm>
-            <a:off x="10341864" y="5632704"/>
-            <a:ext cx="1298448" cy="457200"/>
-          </a:xfrm>
-          <a:prstGeom prst="rect">
-            <a:avLst/>
-          </a:prstGeom>
-          <a:noFill/>
-          <a:ln/>
-        </p:spPr>
-        <p:txBody>
-          <a:bodyPr wrap="square" lIns="0" tIns="0" rIns="0" bIns="0" rtlCol="0" anchor="ctr"/>
-          <a:lstStyle/>
-          <a:p>
-            <a:pPr algn="ctr" indent="0" marL="0">
-              <a:buNone/>
-            </a:pPr>
-            <a:r>
-              <a:rPr lang="en-US" sz="2200" b="1" dirty="0">
-                <a:solidFill>
-                  <a:srgbClr val="F7D060"/>
-                </a:solidFill>
-                <a:latin typeface="Arial" pitchFamily="34" charset="0"/>
-                <a:ea typeface="Arial" pitchFamily="34" charset="-122"/>
-                <a:cs typeface="Arial" pitchFamily="34" charset="-120"/>
-              </a:rPr>
-              <a:t>$0</a:t>
-            </a:r>
-            <a:endParaRPr lang="en-US" sz="2200" dirty="0"/>
-          </a:p>
-        </p:txBody>
-      </p:sp>
-      <p:sp>
-        <p:nvSpPr>
-          <p:cNvPr id="46" name="Text 44"/>
-          <p:cNvSpPr/>
-          <p:nvPr/>
-        </p:nvSpPr>
-        <p:spPr>
-          <a:xfrm>
-            <a:off x="10341864" y="6071616"/>
-            <a:ext cx="1298448" cy="274320"/>
-          </a:xfrm>
-          <a:prstGeom prst="rect">
-            <a:avLst/>
-          </a:prstGeom>
-          <a:noFill/>
-          <a:ln/>
-        </p:spPr>
-        <p:txBody>
-          <a:bodyPr wrap="square" lIns="0" tIns="0" rIns="0" bIns="0" rtlCol="0" anchor="t"/>
-          <a:lstStyle/>
-          <a:p>
-            <a:pPr algn="ctr" indent="0" marL="0">
-              <a:buNone/>
-            </a:pPr>
-            <a:r>
-              <a:rPr lang="en-US" sz="900" dirty="0">
-                <a:solidFill>
-                  <a:srgbClr val="94A0B3"/>
-                </a:solidFill>
-                <a:latin typeface="Arial" pitchFamily="34" charset="0"/>
-                <a:ea typeface="Arial" pitchFamily="34" charset="-122"/>
-                <a:cs typeface="Arial" pitchFamily="34" charset="-120"/>
-              </a:rPr>
-              <a:t>data licenses</a:t>
-            </a:r>
-            <a:endParaRPr lang="en-US" sz="900" dirty="0"/>
-          </a:p>
-        </p:txBody>
-      </p:sp>
-      <p:sp>
-        <p:nvSpPr>
-          <p:cNvPr id="47" name="Text 45"/>
-          <p:cNvSpPr/>
-          <p:nvPr/>
-        </p:nvSpPr>
-        <p:spPr>
-          <a:xfrm>
-            <a:off x="411480" y="6565392"/>
+          <p:cNvPr id="49" name="Text 47"/>
+          <p:cNvSpPr/>
+          <p:nvPr/>
+        </p:nvSpPr>
+        <p:spPr>
+          <a:xfrm>
+            <a:off x="411480" y="6583680"/>
             <a:ext cx="11365992" cy="201168"/>
           </a:xfrm>
           <a:prstGeom prst="rect">

</xml_diff>